<commit_message>
Correct section reference in presentation notes
</commit_message>
<xml_diff>
--- a/Himansh_Raj_Internship_Presentation.pptx
+++ b/Himansh_Raj_Internship_Presentation.pptx
@@ -2,28 +2,28 @@
 <file path=ppt/presentation.xml><?xml version="1.0" encoding="utf-8"?>
 <p:presentation xmlns:p="http://schemas.openxmlformats.org/presentationml/2006/main">
   <p:sldMasterIdLst>
-    <p:sldMasterId xmlns:r="http://schemas.openxmlformats.org/officeDocument/2006/relationships" id="2147483648" r:id="R1206debc817042c6"/>
+    <p:sldMasterId xmlns:r="http://schemas.openxmlformats.org/officeDocument/2006/relationships" id="2147483648" r:id="Rfee3215edfae4b8a"/>
   </p:sldMasterIdLst>
   <p:notesMasterIdLst>
-    <p:notesMasterId xmlns:r="http://schemas.openxmlformats.org/officeDocument/2006/relationships" r:id="R07383ed1c1864e25"/>
+    <p:notesMasterId xmlns:r="http://schemas.openxmlformats.org/officeDocument/2006/relationships" r:id="R5ee9408f35984479"/>
   </p:notesMasterIdLst>
   <p:sldIdLst>
-    <p:sldId xmlns:r="http://schemas.openxmlformats.org/officeDocument/2006/relationships" id="256" r:id="Rbb6a5cc473554c3b"/>
-    <p:sldId xmlns:r="http://schemas.openxmlformats.org/officeDocument/2006/relationships" id="257" r:id="R396b9cf7bf1c45d2"/>
-    <p:sldId xmlns:r="http://schemas.openxmlformats.org/officeDocument/2006/relationships" id="258" r:id="Rc2d7360a64bf4a1a"/>
-    <p:sldId xmlns:r="http://schemas.openxmlformats.org/officeDocument/2006/relationships" id="259" r:id="R8aaeb0d979404a64"/>
-    <p:sldId xmlns:r="http://schemas.openxmlformats.org/officeDocument/2006/relationships" id="260" r:id="R48e43717a7b945ef"/>
-    <p:sldId xmlns:r="http://schemas.openxmlformats.org/officeDocument/2006/relationships" id="261" r:id="Ra64082db659a492b"/>
-    <p:sldId xmlns:r="http://schemas.openxmlformats.org/officeDocument/2006/relationships" id="262" r:id="R286d8540418f41a2"/>
-    <p:sldId xmlns:r="http://schemas.openxmlformats.org/officeDocument/2006/relationships" id="263" r:id="R0c8f8686f4a942c8"/>
-    <p:sldId xmlns:r="http://schemas.openxmlformats.org/officeDocument/2006/relationships" id="264" r:id="R937d647cfb344cd6"/>
-    <p:sldId xmlns:r="http://schemas.openxmlformats.org/officeDocument/2006/relationships" id="265" r:id="R6aeb403d56ef47d6"/>
-    <p:sldId xmlns:r="http://schemas.openxmlformats.org/officeDocument/2006/relationships" id="266" r:id="Rb4ab830aa1744896"/>
-    <p:sldId xmlns:r="http://schemas.openxmlformats.org/officeDocument/2006/relationships" id="267" r:id="Rdf126b1b8c8744f7"/>
-    <p:sldId xmlns:r="http://schemas.openxmlformats.org/officeDocument/2006/relationships" id="268" r:id="R2f1219f44c88485f"/>
-    <p:sldId xmlns:r="http://schemas.openxmlformats.org/officeDocument/2006/relationships" id="269" r:id="R1df237085a524c4c"/>
-    <p:sldId xmlns:r="http://schemas.openxmlformats.org/officeDocument/2006/relationships" id="270" r:id="R88d1c0e8e7904067"/>
-    <p:sldId xmlns:r="http://schemas.openxmlformats.org/officeDocument/2006/relationships" id="271" r:id="R47da63bb96624724"/>
+    <p:sldId xmlns:r="http://schemas.openxmlformats.org/officeDocument/2006/relationships" id="256" r:id="R9de2de2a364e46b7"/>
+    <p:sldId xmlns:r="http://schemas.openxmlformats.org/officeDocument/2006/relationships" id="257" r:id="R802338d1e3b945a4"/>
+    <p:sldId xmlns:r="http://schemas.openxmlformats.org/officeDocument/2006/relationships" id="258" r:id="R7f3ce64ebde24c10"/>
+    <p:sldId xmlns:r="http://schemas.openxmlformats.org/officeDocument/2006/relationships" id="259" r:id="Re9611e0b8191477b"/>
+    <p:sldId xmlns:r="http://schemas.openxmlformats.org/officeDocument/2006/relationships" id="260" r:id="R866c7cf6a4d74c26"/>
+    <p:sldId xmlns:r="http://schemas.openxmlformats.org/officeDocument/2006/relationships" id="261" r:id="R515f52f0cc204625"/>
+    <p:sldId xmlns:r="http://schemas.openxmlformats.org/officeDocument/2006/relationships" id="262" r:id="R8f748703253446ec"/>
+    <p:sldId xmlns:r="http://schemas.openxmlformats.org/officeDocument/2006/relationships" id="263" r:id="R9aea0d0a8c00433b"/>
+    <p:sldId xmlns:r="http://schemas.openxmlformats.org/officeDocument/2006/relationships" id="264" r:id="Rbdcc3b370f974ae1"/>
+    <p:sldId xmlns:r="http://schemas.openxmlformats.org/officeDocument/2006/relationships" id="265" r:id="R501f980d007b42d8"/>
+    <p:sldId xmlns:r="http://schemas.openxmlformats.org/officeDocument/2006/relationships" id="266" r:id="Ra8bce9cecd164d34"/>
+    <p:sldId xmlns:r="http://schemas.openxmlformats.org/officeDocument/2006/relationships" id="267" r:id="R533eaa2d15c84e92"/>
+    <p:sldId xmlns:r="http://schemas.openxmlformats.org/officeDocument/2006/relationships" id="268" r:id="Rb9800edd888f4c16"/>
+    <p:sldId xmlns:r="http://schemas.openxmlformats.org/officeDocument/2006/relationships" id="269" r:id="Rd5329aa21cf4410b"/>
+    <p:sldId xmlns:r="http://schemas.openxmlformats.org/officeDocument/2006/relationships" id="270" r:id="R2a816dedb62246f5"/>
+    <p:sldId xmlns:r="http://schemas.openxmlformats.org/officeDocument/2006/relationships" id="271" r:id="R48e795e8ff524063"/>
   </p:sldIdLst>
   <p:sldSz cx="12192000" cy="6858000"/>
   <p:notesSz cx="6858000" cy="9144000"/>
@@ -457,7 +457,7 @@
           <a:lstStyle xmlns:a="http://schemas.openxmlformats.org/drawingml/2006/main"/>
           <a:p xmlns:a="http://schemas.openxmlformats.org/drawingml/2006/main">
             <a:r>
-              <a:t>Introduce the internship, the host laboratory, and the project title. The semester is presented as VII, consistent with enrollment CS-23411324 in 4CSE1 for Odd 2026–27 and the 2023–2027 cohort.</a:t>
+              <a:t>Introduce the internship, the host laboratory, and the project title. The semester is presented as VII, consistent with enrollment CS-23411324 in CSE1 for Odd 2026–27 and the 2023–2027 cohort.</a:t>
             </a:r>
           </a:p>
           <a:p xmlns:a="http://schemas.openxmlformats.org/drawingml/2006/main">
@@ -1895,7 +1895,7 @@
   </p:cSld>
   <p:clrMap bg1="lt1" tx1="dk1" bg2="lt2" tx2="dk2" accent1="accent1" accent2="accent2" accent3="accent3" accent4="accent4" accent5="accent5" accent6="accent6" hlink="hlink" folHlink="folHlink"/>
   <p:sldLayoutIdLst>
-    <p:sldLayoutId xmlns:r="http://schemas.openxmlformats.org/officeDocument/2006/relationships" id="2147483649" r:id="R79230597ed1448de"/>
+    <p:sldLayoutId xmlns:r="http://schemas.openxmlformats.org/officeDocument/2006/relationships" id="2147483649" r:id="Rfa638c5f6acf402f"/>
   </p:sldLayoutIdLst>
   <p:txStyles>
     <p:titleStyle>
@@ -2961,7 +2961,7 @@
           <p:nvPr/>
         </p:nvPicPr>
         <p:blipFill>
-          <a:blip xmlns:r="http://schemas.openxmlformats.org/officeDocument/2006/relationships" xmlns:a="http://schemas.openxmlformats.org/drawingml/2006/main" r:embed="R84810b0dcf65489d"/>
+          <a:blip xmlns:r="http://schemas.openxmlformats.org/officeDocument/2006/relationships" xmlns:a="http://schemas.openxmlformats.org/drawingml/2006/main" r:embed="R5c040f69d7064a77"/>
           <a:stretch xmlns:a="http://schemas.openxmlformats.org/drawingml/2006/main"/>
         </p:blipFill>
         <p:spPr>
@@ -4233,7 +4233,7 @@
           <p:nvPr/>
         </p:nvPicPr>
         <p:blipFill>
-          <a:blip xmlns:r="http://schemas.openxmlformats.org/officeDocument/2006/relationships" xmlns:a="http://schemas.openxmlformats.org/drawingml/2006/main" r:embed="Reedf7792573242d9"/>
+          <a:blip xmlns:r="http://schemas.openxmlformats.org/officeDocument/2006/relationships" xmlns:a="http://schemas.openxmlformats.org/drawingml/2006/main" r:embed="R2cc77f6565f646ec"/>
           <a:stretch xmlns:a="http://schemas.openxmlformats.org/drawingml/2006/main"/>
         </p:blipFill>
         <p:spPr>
@@ -5016,7 +5016,7 @@
         </p:xfrm>
         <a:graphic xmlns:a="http://schemas.openxmlformats.org/drawingml/2006/main">
           <a:graphicData uri="http://schemas.openxmlformats.org/drawingml/2006/chart">
-            <c:chart xmlns:r="http://schemas.openxmlformats.org/officeDocument/2006/relationships" xmlns:c="http://schemas.openxmlformats.org/drawingml/2006/chart" r:id="R1266fc8580ea4146"/>
+            <c:chart xmlns:r="http://schemas.openxmlformats.org/officeDocument/2006/relationships" xmlns:c="http://schemas.openxmlformats.org/drawingml/2006/chart" r:id="Rb886e05fcbf848e2"/>
           </a:graphicData>
         </a:graphic>
       </p:graphicFrame>
@@ -7287,7 +7287,7 @@
         </p:xfrm>
         <a:graphic xmlns:a="http://schemas.openxmlformats.org/drawingml/2006/main">
           <a:graphicData uri="http://schemas.openxmlformats.org/drawingml/2006/chart">
-            <c:chart xmlns:r="http://schemas.openxmlformats.org/officeDocument/2006/relationships" xmlns:c="http://schemas.openxmlformats.org/drawingml/2006/chart" r:id="R42b98893d916441d"/>
+            <c:chart xmlns:r="http://schemas.openxmlformats.org/officeDocument/2006/relationships" xmlns:c="http://schemas.openxmlformats.org/drawingml/2006/chart" r:id="R36fd0564293d487a"/>
           </a:graphicData>
         </a:graphic>
       </p:graphicFrame>
@@ -16185,7 +16185,7 @@
           <p:nvPr/>
         </p:nvPicPr>
         <p:blipFill>
-          <a:blip xmlns:r="http://schemas.openxmlformats.org/officeDocument/2006/relationships" xmlns:a="http://schemas.openxmlformats.org/drawingml/2006/main" r:embed="R58523df7ee914cee"/>
+          <a:blip xmlns:r="http://schemas.openxmlformats.org/officeDocument/2006/relationships" xmlns:a="http://schemas.openxmlformats.org/drawingml/2006/main" r:embed="Rae8a284999e449b9"/>
           <a:stretch xmlns:a="http://schemas.openxmlformats.org/drawingml/2006/main"/>
         </p:blipFill>
         <p:spPr>
@@ -16624,7 +16624,7 @@
           <p:nvPr/>
         </p:nvPicPr>
         <p:blipFill>
-          <a:blip xmlns:r="http://schemas.openxmlformats.org/officeDocument/2006/relationships" xmlns:a="http://schemas.openxmlformats.org/drawingml/2006/main" r:embed="Rc32544991084440c"/>
+          <a:blip xmlns:r="http://schemas.openxmlformats.org/officeDocument/2006/relationships" xmlns:a="http://schemas.openxmlformats.org/drawingml/2006/main" r:embed="R26d4f445ff8b40a3"/>
           <a:stretch xmlns:a="http://schemas.openxmlformats.org/drawingml/2006/main"/>
         </p:blipFill>
         <p:spPr>

</xml_diff>